<commit_message>
docs: add full official member roster (6 students), FPT University, MAS291, Nhóm 1, and instructor nhannxv
</commit_message>
<xml_diff>
--- a/outputs/reports/Computer_Project_Topic_1_Slides.pptx
+++ b/outputs/reports/Computer_Project_Topic_1_Slides.pptx
@@ -3150,8 +3150,8 @@
         </p:nvSpPr>
         <p:spPr>
           <a:xfrm>
-            <a:off x="914400" y="1097280"/>
-            <a:ext cx="10362895" cy="4114800"/>
+            <a:off x="731520" y="731520"/>
+            <a:ext cx="10728655" cy="5486400"/>
           </a:xfrm>
           <a:prstGeom prst="rect">
             <a:avLst/>
@@ -3165,22 +3165,22 @@
           <a:lstStyle/>
           <a:p>
             <a:pPr>
-              <a:defRPr sz="1400" b="1">
+              <a:defRPr sz="1300" b="1">
                 <a:solidFill>
                   <a:srgbClr val="C8E1FF"/>
                 </a:solidFill>
               </a:defRPr>
             </a:pPr>
             <a:r>
-              <a:t>BÀI TẬP LỚN MÁY TÍNH — XÁC SUẤT &amp; THỐNG KÊ ỨNG DỤNG</a:t>
+              <a:t>TRƯỜNG ĐẠI HỌC FPT — BÀI TẬP LỚN MÁY TÍNH (COMPUTER PROJECT)</a:t>
             </a:r>
           </a:p>
           <a:p>
             <a:pPr>
               <a:spcBef>
-                <a:spcPts val="1600"/>
+                <a:spcPts val="800"/>
               </a:spcBef>
-              <a:defRPr sz="3200" b="1">
+              <a:defRPr sz="2800" b="1">
                 <a:solidFill>
                   <a:srgbClr val="FFFFFF"/>
                 </a:solidFill>
@@ -3193,9 +3193,9 @@
           <a:p>
             <a:pPr>
               <a:spcBef>
-                <a:spcPts val="1200"/>
+                <a:spcPts val="600"/>
               </a:spcBef>
-              <a:defRPr sz="1800" i="1">
+              <a:defRPr sz="1400" i="1">
                 <a:solidFill>
                   <a:srgbClr val="E6F0FF"/>
                 </a:solidFill>
@@ -3208,16 +3208,121 @@
           <a:p>
             <a:pPr>
               <a:spcBef>
-                <a:spcPts val="3600"/>
+                <a:spcPts val="1000"/>
               </a:spcBef>
-              <a:defRPr sz="1400">
-                <a:solidFill>
-                  <a:srgbClr val="B4D2F0"/>
-                </a:solidFill>
-              </a:defRPr>
-            </a:pPr>
-            <a:r>
-              <a:t>Nhóm thực hiện: 6 thành viên  |  Dữ liệu khảo sát thực tế: n = 32  |  Học kỳ: 2025–2026</a:t>
+              <a:defRPr sz="1300" b="1">
+                <a:solidFill>
+                  <a:srgbClr val="FFD700"/>
+                </a:solidFill>
+              </a:defRPr>
+            </a:pPr>
+            <a:r>
+              <a:t>Học phần: MAS291 (Xác suất &amp; Thống kê ứng dụng)  |  Lớp: MAS291  |  Nhóm: Nhóm 1  |  GVHD: nhannxv</a:t>
+            </a:r>
+          </a:p>
+          <a:p>
+            <a:pPr>
+              <a:spcBef>
+                <a:spcPts val="1400"/>
+              </a:spcBef>
+              <a:defRPr sz="1200" b="1">
+                <a:solidFill>
+                  <a:srgbClr val="FFFFFF"/>
+                </a:solidFill>
+              </a:defRPr>
+            </a:pPr>
+            <a:r>
+              <a:t>DANH SÁCH THÀNH VIÊN NHÓM 1 THỰC HIỆN:</a:t>
+            </a:r>
+          </a:p>
+          <a:p>
+            <a:pPr>
+              <a:spcBef>
+                <a:spcPts val="300"/>
+              </a:spcBef>
+              <a:defRPr sz="1150">
+                <a:solidFill>
+                  <a:srgbClr val="D7EBFF"/>
+                </a:solidFill>
+              </a:defRPr>
+            </a:pPr>
+            <a:r>
+              <a:t>• 1. Mai Xuân Hiếu — MSSV: DE200199 (Nhóm trưởng / Mở đầu &amp; Làm sạch)</a:t>
+            </a:r>
+          </a:p>
+          <a:p>
+            <a:pPr>
+              <a:spcBef>
+                <a:spcPts val="300"/>
+              </a:spcBef>
+              <a:defRPr sz="1150">
+                <a:solidFill>
+                  <a:srgbClr val="D7EBFF"/>
+                </a:solidFill>
+              </a:defRPr>
+            </a:pPr>
+            <a:r>
+              <a:t>• 2. Nguyễn Hữu Hoàng Thắng — MSSV: DE200281 (Thống kê mô tả &amp; Phân phối)</a:t>
+            </a:r>
+          </a:p>
+          <a:p>
+            <a:pPr>
+              <a:spcBef>
+                <a:spcPts val="300"/>
+              </a:spcBef>
+              <a:defRPr sz="1150">
+                <a:solidFill>
+                  <a:srgbClr val="D7EBFF"/>
+                </a:solidFill>
+              </a:defRPr>
+            </a:pPr>
+            <a:r>
+              <a:t>• 3. Trần Đức Duy — MSSV: DE180206 (Tương quan Pearson &amp; Hồi quy OLS)</a:t>
+            </a:r>
+          </a:p>
+          <a:p>
+            <a:pPr>
+              <a:spcBef>
+                <a:spcPts val="300"/>
+              </a:spcBef>
+              <a:defRPr sz="1150">
+                <a:solidFill>
+                  <a:srgbClr val="D7EBFF"/>
+                </a:solidFill>
+              </a:defRPr>
+            </a:pPr>
+            <a:r>
+              <a:t>• 4. Phan Dương Sinh — MSSV: DE200235 (Chẩn đoán giả định Gauss-Markov)</a:t>
+            </a:r>
+          </a:p>
+          <a:p>
+            <a:pPr>
+              <a:spcBef>
+                <a:spcPts val="300"/>
+              </a:spcBef>
+              <a:defRPr sz="1150">
+                <a:solidFill>
+                  <a:srgbClr val="D7EBFF"/>
+                </a:solidFill>
+              </a:defRPr>
+            </a:pPr>
+            <a:r>
+              <a:t>• 5. Võ Ngọc Minh Quân — MSSV: DE200080 (Khoảng tin cậy &amp; Kiểm định giả thuyết)</a:t>
+            </a:r>
+          </a:p>
+          <a:p>
+            <a:pPr>
+              <a:spcBef>
+                <a:spcPts val="300"/>
+              </a:spcBef>
+              <a:defRPr sz="1150">
+                <a:solidFill>
+                  <a:srgbClr val="D7EBFF"/>
+                </a:solidFill>
+              </a:defRPr>
+            </a:pPr>
+            <a:r>
+              <a:t>• 6. Vũ Hữu Thái — MSSV: DE200132 (Dự đoán điểm, Giới hạn thực nghiệm &amp; Tổng kết)</a:t>
             </a:r>
           </a:p>
         </p:txBody>
@@ -3400,7 +3505,7 @@
               </a:defRPr>
             </a:pPr>
             <a:r>
-              <a:t>Thành viên 6</a:t>
+              <a:t>Vũ Hữu Thái (DE200132)</a:t>
             </a:r>
           </a:p>
         </p:txBody>
@@ -3975,7 +4080,7 @@
               </a:defRPr>
             </a:pPr>
             <a:r>
-              <a:t>Thành viên 6</a:t>
+              <a:t>Vũ Hữu Thái (DE200132)</a:t>
             </a:r>
           </a:p>
         </p:txBody>
@@ -4410,7 +4515,7 @@
               </a:defRPr>
             </a:pPr>
             <a:r>
-              <a:t>Thành viên 6</a:t>
+              <a:t>Vũ Hữu Thái (DE200132)</a:t>
             </a:r>
           </a:p>
         </p:txBody>
@@ -4848,7 +4953,7 @@
               </a:defRPr>
             </a:pPr>
             <a:r>
-              <a:t>Thành viên 1</a:t>
+              <a:t>Mai Xuân Hiếu (DE200199)</a:t>
             </a:r>
           </a:p>
         </p:txBody>
@@ -5415,7 +5520,7 @@
               </a:defRPr>
             </a:pPr>
             <a:r>
-              <a:t>Thành viên 2</a:t>
+              <a:t>Nguyễn Hữu Hoàng Thắng (DE200281)</a:t>
             </a:r>
           </a:p>
         </p:txBody>
@@ -6549,7 +6654,7 @@
               </a:defRPr>
             </a:pPr>
             <a:r>
-              <a:t>Thành viên 2</a:t>
+              <a:t>Nguyễn Hữu Hoàng Thắng (DE200281)</a:t>
             </a:r>
           </a:p>
         </p:txBody>
@@ -6857,7 +6962,7 @@
               </a:defRPr>
             </a:pPr>
             <a:r>
-              <a:t>Thành viên 3</a:t>
+              <a:t>Trần Đức Duy (DE180206)</a:t>
             </a:r>
           </a:p>
         </p:txBody>
@@ -7256,7 +7361,7 @@
               </a:defRPr>
             </a:pPr>
             <a:r>
-              <a:t>Thành viên 3</a:t>
+              <a:t>Trần Đức Duy (DE180206)</a:t>
             </a:r>
           </a:p>
         </p:txBody>
@@ -7624,7 +7729,7 @@
               </a:defRPr>
             </a:pPr>
             <a:r>
-              <a:t>Thành viên 4</a:t>
+              <a:t>Phan Dương Sinh (DE200235)</a:t>
             </a:r>
           </a:p>
         </p:txBody>
@@ -8143,7 +8248,7 @@
               </a:defRPr>
             </a:pPr>
             <a:r>
-              <a:t>Thành viên 5</a:t>
+              <a:t>Võ Ngọc Minh Quân (DE200080)</a:t>
             </a:r>
           </a:p>
         </p:txBody>
@@ -8756,7 +8861,7 @@
               </a:defRPr>
             </a:pPr>
             <a:r>
-              <a:t>Thành viên 5</a:t>
+              <a:t>Võ Ngọc Minh Quân (DE200080)</a:t>
             </a:r>
           </a:p>
         </p:txBody>

</xml_diff>

<commit_message>
fix(roster): reorder team members 1 to 6 (1: Hiếu, 2: Sinh, 3: Quân, 4: Thái, 5: Thắng, 6: Duy)
</commit_message>
<xml_diff>
--- a/outputs/reports/Computer_Project_Topic_1_Slides.pptx
+++ b/outputs/reports/Computer_Project_Topic_1_Slides.pptx
@@ -3262,7 +3262,7 @@
               </a:defRPr>
             </a:pPr>
             <a:r>
-              <a:t>• 2. Nguyễn Hữu Hoàng Thắng — MSSV: DE200281 (Thống kê mô tả &amp; Phân phối)</a:t>
+              <a:t>• 2. Phan Dương Sinh — MSSV: DE200235 (Thống kê mô tả &amp; Phân phối)</a:t>
             </a:r>
           </a:p>
           <a:p>
@@ -3277,7 +3277,7 @@
               </a:defRPr>
             </a:pPr>
             <a:r>
-              <a:t>• 3. Trần Đức Duy — MSSV: DE180206 (Tương quan Pearson &amp; Hồi quy OLS)</a:t>
+              <a:t>• 3. Võ Ngọc Minh Quân — MSSV: DE200080 (Tương quan Pearson &amp; Hồi quy OLS)</a:t>
             </a:r>
           </a:p>
           <a:p>
@@ -3292,7 +3292,7 @@
               </a:defRPr>
             </a:pPr>
             <a:r>
-              <a:t>• 4. Phan Dương Sinh — MSSV: DE200235 (Chẩn đoán giả định Gauss-Markov)</a:t>
+              <a:t>• 4. Vũ Hữu Thái — MSSV: DE200132 (Chẩn đoán giả định Gauss-Markov)</a:t>
             </a:r>
           </a:p>
           <a:p>
@@ -3307,7 +3307,7 @@
               </a:defRPr>
             </a:pPr>
             <a:r>
-              <a:t>• 5. Võ Ngọc Minh Quân — MSSV: DE200080 (Khoảng tin cậy &amp; Kiểm định giả thuyết)</a:t>
+              <a:t>• 5. Nguyễn Hữu Hoàng Thắng — MSSV: DE200281 (Khoảng tin cậy &amp; Kiểm định giả thuyết)</a:t>
             </a:r>
           </a:p>
           <a:p>
@@ -3322,7 +3322,7 @@
               </a:defRPr>
             </a:pPr>
             <a:r>
-              <a:t>• 6. Vũ Hữu Thái — MSSV: DE200132 (Dự đoán điểm, Giới hạn thực nghiệm &amp; Tổng kết)</a:t>
+              <a:t>• 6. Trần Đức Duy — MSSV: DE180206 (Dự đoán điểm, Giới hạn thực nghiệm &amp; Tổng kết)</a:t>
             </a:r>
           </a:p>
         </p:txBody>
@@ -3505,7 +3505,7 @@
               </a:defRPr>
             </a:pPr>
             <a:r>
-              <a:t>Vũ Hữu Thái (DE200132)</a:t>
+              <a:t>Trần Đức Duy (DE180206)</a:t>
             </a:r>
           </a:p>
         </p:txBody>
@@ -4080,7 +4080,7 @@
               </a:defRPr>
             </a:pPr>
             <a:r>
-              <a:t>Vũ Hữu Thái (DE200132)</a:t>
+              <a:t>Trần Đức Duy (DE180206)</a:t>
             </a:r>
           </a:p>
         </p:txBody>
@@ -4515,7 +4515,7 @@
               </a:defRPr>
             </a:pPr>
             <a:r>
-              <a:t>Vũ Hữu Thái (DE200132)</a:t>
+              <a:t>Trần Đức Duy (DE180206)</a:t>
             </a:r>
           </a:p>
         </p:txBody>
@@ -5520,7 +5520,7 @@
               </a:defRPr>
             </a:pPr>
             <a:r>
-              <a:t>Nguyễn Hữu Hoàng Thắng (DE200281)</a:t>
+              <a:t>Phan Dương Sinh (DE200235)</a:t>
             </a:r>
           </a:p>
         </p:txBody>
@@ -6654,7 +6654,7 @@
               </a:defRPr>
             </a:pPr>
             <a:r>
-              <a:t>Nguyễn Hữu Hoàng Thắng (DE200281)</a:t>
+              <a:t>Phan Dương Sinh (DE200235)</a:t>
             </a:r>
           </a:p>
         </p:txBody>
@@ -6962,7 +6962,7 @@
               </a:defRPr>
             </a:pPr>
             <a:r>
-              <a:t>Trần Đức Duy (DE180206)</a:t>
+              <a:t>Võ Ngọc Minh Quân (DE200080)</a:t>
             </a:r>
           </a:p>
         </p:txBody>
@@ -7361,7 +7361,7 @@
               </a:defRPr>
             </a:pPr>
             <a:r>
-              <a:t>Trần Đức Duy (DE180206)</a:t>
+              <a:t>Võ Ngọc Minh Quân (DE200080)</a:t>
             </a:r>
           </a:p>
         </p:txBody>
@@ -7729,7 +7729,7 @@
               </a:defRPr>
             </a:pPr>
             <a:r>
-              <a:t>Phan Dương Sinh (DE200235)</a:t>
+              <a:t>Vũ Hữu Thái (DE200132)</a:t>
             </a:r>
           </a:p>
         </p:txBody>
@@ -8248,7 +8248,7 @@
               </a:defRPr>
             </a:pPr>
             <a:r>
-              <a:t>Võ Ngọc Minh Quân (DE200080)</a:t>
+              <a:t>Nguyễn Hữu Hoàng Thắng (DE200281)</a:t>
             </a:r>
           </a:p>
         </p:txBody>
@@ -8861,7 +8861,7 @@
               </a:defRPr>
             </a:pPr>
             <a:r>
-              <a:t>Võ Ngọc Minh Quân (DE200080)</a:t>
+              <a:t>Nguyễn Hữu Hoàng Thắng (DE200281)</a:t>
             </a:r>
           </a:p>
         </p:txBody>

</xml_diff>